<commit_message>
Add time series forecasting notes and practice script
- Created a new markdown file for time series machine learning notes, covering forecasting procedures, baselines, backtesting, feature-based models, and pitfalls.
- Implemented a practice script to run Python code blocks from notes in a shared namespace, allowing for easy execution of examples.
- Added a PDF slide for agentic foundations in generative AI.
</commit_message>
<xml_diff>
--- a/generative-ai/03-agentic-foundations/slides/agentic-foundations.pptx
+++ b/generative-ai/03-agentic-foundations/slides/agentic-foundations.pptx
@@ -13530,7 +13530,7 @@
       </p:sp>
       <p:pic>
         <p:nvPicPr>
-          <p:cNvPr id="14" name="Picture 13" descr="packer-wooders-agent-memory-fig5-2379686319999954282.jpg"/>
+          <p:cNvPr id="14" name="Picture 13" descr="packer-wooders-agent-memory-fig5-4347738712642123198.jpg"/>
           <p:cNvPicPr>
             <a:picLocks noChangeAspect="1"/>
           </p:cNvPicPr>
@@ -14308,7 +14308,7 @@
         <p:spPr>
           <a:xfrm>
             <a:off x="502920" y="1472184"/>
-            <a:ext cx="6711513" cy="3672840"/>
+            <a:ext cx="6711513" cy="3657600"/>
           </a:xfrm>
           <a:prstGeom prst="roundRect">
             <a:avLst>
@@ -14393,7 +14393,7 @@
         <p:spPr>
           <a:xfrm>
             <a:off x="731520" y="1883664"/>
-            <a:ext cx="6254313" cy="3032760"/>
+            <a:ext cx="6254313" cy="3017520"/>
           </a:xfrm>
           <a:prstGeom prst="rect">
             <a:avLst/>
@@ -14412,7 +14412,7 @@
               </a:lnSpc>
             </a:pPr>
             <a:r>
-              <a:rPr sz="1400" i="0" b="0">
+              <a:rPr sz="1500" i="0" b="0">
                 <a:solidFill>
                   <a:srgbClr val="E2E8F0"/>
                 </a:solidFill>
@@ -14428,13 +14428,13 @@
               </a:lnSpc>
             </a:pPr>
             <a:r>
-              <a:rPr sz="1400" i="0" b="0">
+              <a:rPr sz="1500" i="0" b="0">
                 <a:solidFill>
                   <a:srgbClr val="E2E8F0"/>
                 </a:solidFill>
                 <a:latin typeface="Menlo"/>
               </a:rPr>
-              <a:t>Error: core is full (limit 100). Move detail to the archive.</a:t>
+              <a:t>Error: core is full (limit 100). Move detail...</a:t>
             </a:r>
           </a:p>
           <a:p>
@@ -14444,7 +14444,7 @@
               </a:lnSpc>
             </a:pPr>
             <a:r>
-              <a:rPr sz="1400" i="0" b="0">
+              <a:rPr sz="1500" i="0" b="0">
                 <a:solidFill>
                   <a:srgbClr val="E2E8F0"/>
                 </a:solidFill>
@@ -14460,7 +14460,7 @@
               </a:lnSpc>
             </a:pPr>
             <a:r>
-              <a:rPr sz="1400" i="0" b="0">
+              <a:rPr sz="1500" i="0" b="0">
                 <a:solidFill>
                   <a:srgbClr val="E2E8F0"/>
                 </a:solidFill>
@@ -14483,7 +14483,7 @@
               </a:lnSpc>
             </a:pPr>
             <a:r>
-              <a:rPr sz="1400" i="0" b="0">
+              <a:rPr sz="1500" i="0" b="0">
                 <a:solidFill>
                   <a:srgbClr val="E2E8F0"/>
                 </a:solidFill>
@@ -14499,7 +14499,7 @@
               </a:lnSpc>
             </a:pPr>
             <a:r>
-              <a:rPr sz="1400" i="0" b="0">
+              <a:rPr sz="1500" i="0" b="0">
                 <a:solidFill>
                   <a:srgbClr val="E2E8F0"/>
                 </a:solidFill>
@@ -14515,13 +14515,13 @@
               </a:lnSpc>
             </a:pPr>
             <a:r>
-              <a:rPr sz="1400" i="0" b="0">
+              <a:rPr sz="1500" i="0" b="0">
                 <a:solidFill>
                   <a:srgbClr val="E2E8F0"/>
                 </a:solidFill>
                 <a:latin typeface="Menlo"/>
               </a:rPr>
-              <a:t>&lt;supplier&gt;Acme delivers itemB. See archive: ...&lt;/supplier&gt;</a:t>
+              <a:t>&lt;supplier&gt;Acme delivers itemB. See...&lt;/supplier&gt;</a:t>
             </a:r>
           </a:p>
           <a:p>
@@ -14531,7 +14531,7 @@
               </a:lnSpc>
             </a:pPr>
             <a:r>
-              <a:rPr sz="1400" i="0" b="0">
+              <a:rPr sz="1500" i="0" b="0">
                 <a:solidFill>
                   <a:srgbClr val="E2E8F0"/>
                 </a:solidFill>
@@ -14554,7 +14554,7 @@
               </a:lnSpc>
             </a:pPr>
             <a:r>
-              <a:rPr sz="1400" i="0" b="0">
+              <a:rPr sz="1500" i="0" b="0">
                 <a:solidFill>
                   <a:srgbClr val="E2E8F0"/>
                 </a:solidFill>
@@ -14570,7 +14570,7 @@
               </a:lnSpc>
             </a:pPr>
             <a:r>
-              <a:rPr sz="1400" i="0" b="0">
+              <a:rPr sz="1500" i="0" b="0">
                 <a:solidFill>
                   <a:srgbClr val="E2E8F0"/>
                 </a:solidFill>
@@ -28249,7 +28249,7 @@
         <p:spPr>
           <a:xfrm>
             <a:off x="502920" y="1472184"/>
-            <a:ext cx="6711513" cy="2392680"/>
+            <a:ext cx="6711513" cy="2148839"/>
           </a:xfrm>
           <a:prstGeom prst="roundRect">
             <a:avLst>
@@ -28334,7 +28334,7 @@
         <p:spPr>
           <a:xfrm>
             <a:off x="731520" y="1883664"/>
-            <a:ext cx="6254313" cy="1752599"/>
+            <a:ext cx="6254313" cy="1508759"/>
           </a:xfrm>
           <a:prstGeom prst="rect">
             <a:avLst/>
@@ -28391,7 +28391,7 @@
                 </a:solidFill>
                 <a:latin typeface="Menlo"/>
               </a:rPr>
-              <a:t>level 3:  6500 tokens  only if the body points there</a:t>
+              <a:t>level 3:  6500 tokens  only if the body says</a:t>
             </a:r>
           </a:p>
           <a:p>
@@ -32227,7 +32227,23 @@
                 </a:solidFill>
                 <a:latin typeface="Menlo"/>
               </a:rPr>
-              <a:t>    if tool == "place_order" and args["quantity"] &gt; 500:</a:t>
+              <a:t>    if (tool == "place_order"</a:t>
+            </a:r>
+          </a:p>
+          <a:p>
+            <a:pPr algn="l">
+              <a:lnSpc>
+                <a:spcPct val="100000"/>
+              </a:lnSpc>
+            </a:pPr>
+            <a:r>
+              <a:rPr sz="1600" i="0" b="0">
+                <a:solidFill>
+                  <a:srgbClr val="E2E8F0"/>
+                </a:solidFill>
+                <a:latin typeface="Menlo"/>
+              </a:rPr>
+              <a:t>        and args["quantity"] &gt; 500):</a:t>
             </a:r>
           </a:p>
           <a:p>
@@ -36559,7 +36575,7 @@
         <p:spPr>
           <a:xfrm>
             <a:off x="502920" y="1472184"/>
-            <a:ext cx="6711513" cy="3611879"/>
+            <a:ext cx="6711513" cy="3368040"/>
           </a:xfrm>
           <a:prstGeom prst="roundRect">
             <a:avLst>
@@ -36644,7 +36660,7 @@
         <p:spPr>
           <a:xfrm>
             <a:off x="731520" y="1883664"/>
-            <a:ext cx="6254313" cy="2971799"/>
+            <a:ext cx="6254313" cy="2727959"/>
           </a:xfrm>
           <a:prstGeom prst="rect">
             <a:avLst/>
@@ -36685,7 +36701,7 @@
                 </a:solidFill>
                 <a:latin typeface="Menlo"/>
               </a:rPr>
-              <a:t>itemA: 3.0 weeks of cover, 2 to deliver -&gt; ok</a:t>
+              <a:t>itemA: 3.0 cover, 2 to deliver -&gt; ok</a:t>
             </a:r>
           </a:p>
           <a:p>
@@ -36701,7 +36717,7 @@
                 </a:solidFill>
                 <a:latin typeface="Menlo"/>
               </a:rPr>
-              <a:t>itemB: 1.1 weeks of cover, 2 to deliver -&gt; ORDER NOW</a:t>
+              <a:t>itemB: 1.1 cover, 2 to deliver -&gt; ORDER NOW</a:t>
             </a:r>
           </a:p>
           <a:p>
@@ -36717,7 +36733,7 @@
                 </a:solidFill>
                 <a:latin typeface="Menlo"/>
               </a:rPr>
-              <a:t>itemC: 2.2 weeks of cover, 1 to deliver -&gt; ok</a:t>
+              <a:t>itemC: 2.2 cover, 1 to deliver -&gt; ok</a:t>
             </a:r>
           </a:p>
           <a:p>
@@ -37581,7 +37597,7 @@
       </p:sp>
       <p:pic>
         <p:nvPicPr>
-          <p:cNvPr id="13" name="Picture 12" descr="li-ai-agents-in-depth-fig1-1-6945095176422174168.png"/>
+          <p:cNvPr id="13" name="Picture 12" descr="li-ai-agents-in-depth-fig1-1-914697608439795640.png"/>
           <p:cNvPicPr>
             <a:picLocks noChangeAspect="1"/>
           </p:cNvPicPr>

</xml_diff>